<commit_message>
docs: translate API.md and README.md to English
</commit_message>
<xml_diff>
--- a/Presentation.pptx
+++ b/Presentation.pptx
@@ -311,7 +311,7 @@
           <a:p>
             <a:fld id="{5BCAD085-E8A6-8845-BD4E-CB4CCA059FC4}" type="datetimeFigureOut">
               <a:rPr lang="en-US" smtClean="0"/>
-              <a:t>3/21/26</a:t>
+              <a:t>3/25/26</a:t>
             </a:fld>
             <a:endParaRPr lang="en-US"/>
           </a:p>
@@ -479,7 +479,7 @@
           <a:p>
             <a:fld id="{5BCAD085-E8A6-8845-BD4E-CB4CCA059FC4}" type="datetimeFigureOut">
               <a:rPr lang="en-US" smtClean="0"/>
-              <a:t>3/21/26</a:t>
+              <a:t>3/25/26</a:t>
             </a:fld>
             <a:endParaRPr lang="en-US"/>
           </a:p>
@@ -657,7 +657,7 @@
           <a:p>
             <a:fld id="{5BCAD085-E8A6-8845-BD4E-CB4CCA059FC4}" type="datetimeFigureOut">
               <a:rPr lang="en-US" smtClean="0"/>
-              <a:t>3/21/26</a:t>
+              <a:t>3/25/26</a:t>
             </a:fld>
             <a:endParaRPr lang="en-US"/>
           </a:p>
@@ -825,7 +825,7 @@
           <a:p>
             <a:fld id="{5BCAD085-E8A6-8845-BD4E-CB4CCA059FC4}" type="datetimeFigureOut">
               <a:rPr lang="en-US" smtClean="0"/>
-              <a:t>3/21/26</a:t>
+              <a:t>3/25/26</a:t>
             </a:fld>
             <a:endParaRPr lang="en-US"/>
           </a:p>
@@ -1070,7 +1070,7 @@
           <a:p>
             <a:fld id="{5BCAD085-E8A6-8845-BD4E-CB4CCA059FC4}" type="datetimeFigureOut">
               <a:rPr lang="en-US" smtClean="0"/>
-              <a:t>3/21/26</a:t>
+              <a:t>3/25/26</a:t>
             </a:fld>
             <a:endParaRPr lang="en-US"/>
           </a:p>
@@ -1355,7 +1355,7 @@
           <a:p>
             <a:fld id="{5BCAD085-E8A6-8845-BD4E-CB4CCA059FC4}" type="datetimeFigureOut">
               <a:rPr lang="en-US" smtClean="0"/>
-              <a:t>3/21/26</a:t>
+              <a:t>3/25/26</a:t>
             </a:fld>
             <a:endParaRPr lang="en-US"/>
           </a:p>
@@ -1774,7 +1774,7 @@
           <a:p>
             <a:fld id="{5BCAD085-E8A6-8845-BD4E-CB4CCA059FC4}" type="datetimeFigureOut">
               <a:rPr lang="en-US" smtClean="0"/>
-              <a:t>3/21/26</a:t>
+              <a:t>3/25/26</a:t>
             </a:fld>
             <a:endParaRPr lang="en-US"/>
           </a:p>
@@ -1891,7 +1891,7 @@
           <a:p>
             <a:fld id="{5BCAD085-E8A6-8845-BD4E-CB4CCA059FC4}" type="datetimeFigureOut">
               <a:rPr lang="en-US" smtClean="0"/>
-              <a:t>3/21/26</a:t>
+              <a:t>3/25/26</a:t>
             </a:fld>
             <a:endParaRPr lang="en-US"/>
           </a:p>
@@ -1986,7 +1986,7 @@
           <a:p>
             <a:fld id="{5BCAD085-E8A6-8845-BD4E-CB4CCA059FC4}" type="datetimeFigureOut">
               <a:rPr lang="en-US" smtClean="0"/>
-              <a:t>3/21/26</a:t>
+              <a:t>3/25/26</a:t>
             </a:fld>
             <a:endParaRPr lang="en-US"/>
           </a:p>
@@ -2261,7 +2261,7 @@
           <a:p>
             <a:fld id="{5BCAD085-E8A6-8845-BD4E-CB4CCA059FC4}" type="datetimeFigureOut">
               <a:rPr lang="en-US" smtClean="0"/>
-              <a:t>3/21/26</a:t>
+              <a:t>3/25/26</a:t>
             </a:fld>
             <a:endParaRPr lang="en-US"/>
           </a:p>
@@ -2513,7 +2513,7 @@
           <a:p>
             <a:fld id="{5BCAD085-E8A6-8845-BD4E-CB4CCA059FC4}" type="datetimeFigureOut">
               <a:rPr lang="en-US" smtClean="0"/>
-              <a:t>3/21/26</a:t>
+              <a:t>3/25/26</a:t>
             </a:fld>
             <a:endParaRPr lang="en-US"/>
           </a:p>
@@ -2724,7 +2724,7 @@
           <a:p>
             <a:fld id="{5BCAD085-E8A6-8845-BD4E-CB4CCA059FC4}" type="datetimeFigureOut">
               <a:rPr lang="en-US" smtClean="0"/>
-              <a:t>3/21/26</a:t>
+              <a:t>3/25/26</a:t>
             </a:fld>
             <a:endParaRPr lang="en-US"/>
           </a:p>
@@ -3160,7 +3160,7 @@
         <p:spPr>
           <a:xfrm>
             <a:off x="1371600" y="1645920"/>
-            <a:ext cx="9144000" cy="1097280"/>
+            <a:ext cx="9144000" cy="1015663"/>
           </a:xfrm>
           <a:prstGeom prst="rect">
             <a:avLst/>
@@ -3182,8 +3182,14 @@
               </a:defRPr>
             </a:pPr>
             <a:r>
-              <a:t>🐋  Orca</a:t>
-            </a:r>
+              <a:rPr dirty="0"/>
+              <a:t>🐋  </a:t>
+            </a:r>
+            <a:r>
+              <a:rPr lang="en-US" dirty="0" err="1"/>
+              <a:t>PayLock</a:t>
+            </a:r>
+            <a:endParaRPr dirty="0"/>
           </a:p>
         </p:txBody>
       </p:sp>
@@ -3254,6 +3260,7 @@
               </a:defRPr>
             </a:pPr>
             <a:r>
+              <a:rPr dirty="0"/>
               <a:t>Decentralized Video Paywall SDK for Sui</a:t>
             </a:r>
           </a:p>
@@ -3311,8 +3318,8 @@
         </p:nvSpPr>
         <p:spPr>
           <a:xfrm>
-            <a:off x="3200400" y="4389120"/>
-            <a:ext cx="5943600" cy="1371600"/>
+            <a:off x="3088888" y="4389120"/>
+            <a:ext cx="6055112" cy="748923"/>
           </a:xfrm>
           <a:prstGeom prst="rect">
             <a:avLst/>
@@ -3331,7 +3338,7 @@
               </a:spcAft>
             </a:pPr>
             <a:r>
-              <a:rPr sz="1400">
+              <a:rPr sz="1400" dirty="0">
                 <a:solidFill>
                   <a:srgbClr val="38BDF8"/>
                 </a:solidFill>
@@ -3340,13 +3347,22 @@
               <a:t>●  </a:t>
             </a:r>
             <a:r>
-              <a:rPr sz="1800">
+              <a:rPr sz="1800" dirty="0" err="1">
                 <a:solidFill>
                   <a:srgbClr val="94A3B8"/>
                 </a:solidFill>
                 <a:latin typeface="Calibri"/>
               </a:rPr>
-              <a:t>核心技術：Walrus + Seal</a:t>
+              <a:t>核心技術：Walrus</a:t>
+            </a:r>
+            <a:r>
+              <a:rPr sz="1800" dirty="0">
+                <a:solidFill>
+                  <a:srgbClr val="94A3B8"/>
+                </a:solidFill>
+                <a:latin typeface="Calibri"/>
+              </a:rPr>
+              <a:t> + Seal</a:t>
             </a:r>
           </a:p>
           <a:p>
@@ -3356,7 +3372,7 @@
               </a:spcAft>
             </a:pPr>
             <a:r>
-              <a:rPr sz="1400">
+              <a:rPr sz="1400" dirty="0">
                 <a:solidFill>
                   <a:srgbClr val="38BDF8"/>
                 </a:solidFill>
@@ -3365,14 +3381,56 @@
               <a:t>●  </a:t>
             </a:r>
             <a:r>
-              <a:rPr sz="1800">
+              <a:rPr sz="1800" dirty="0" err="1">
                 <a:solidFill>
                   <a:srgbClr val="94A3B8"/>
                 </a:solidFill>
                 <a:latin typeface="Calibri"/>
               </a:rPr>
-              <a:t>願景：只需幾行程式碼，為任何 dApp 加入影片付費功能</a:t>
-            </a:r>
+              <a:t>願景：只需幾行程式碼，為任何</a:t>
+            </a:r>
+            <a:r>
+              <a:rPr sz="1800" dirty="0">
+                <a:solidFill>
+                  <a:srgbClr val="94A3B8"/>
+                </a:solidFill>
+                <a:latin typeface="Calibri"/>
+              </a:rPr>
+              <a:t> </a:t>
+            </a:r>
+            <a:r>
+              <a:rPr sz="1800" dirty="0" err="1">
+                <a:solidFill>
+                  <a:srgbClr val="94A3B8"/>
+                </a:solidFill>
+                <a:latin typeface="Calibri"/>
+              </a:rPr>
+              <a:t>dApp</a:t>
+            </a:r>
+            <a:r>
+              <a:rPr sz="1800" dirty="0">
+                <a:solidFill>
+                  <a:srgbClr val="94A3B8"/>
+                </a:solidFill>
+                <a:latin typeface="Calibri"/>
+              </a:rPr>
+              <a:t> </a:t>
+            </a:r>
+            <a:r>
+              <a:rPr sz="1800" dirty="0" err="1">
+                <a:solidFill>
+                  <a:srgbClr val="94A3B8"/>
+                </a:solidFill>
+                <a:latin typeface="Calibri"/>
+              </a:rPr>
+              <a:t>加入影片付費功能</a:t>
+            </a:r>
+            <a:endParaRPr sz="1800" dirty="0">
+              <a:solidFill>
+                <a:srgbClr val="94A3B8"/>
+              </a:solidFill>
+              <a:latin typeface="Calibri"/>
+            </a:endParaRPr>
           </a:p>
         </p:txBody>
       </p:sp>
@@ -3854,7 +3912,7 @@
         <p:spPr>
           <a:xfrm>
             <a:off x="2560320" y="4526280"/>
-            <a:ext cx="1371600" cy="365760"/>
+            <a:ext cx="1371600" cy="400110"/>
           </a:xfrm>
           <a:prstGeom prst="rect">
             <a:avLst/>
@@ -3876,8 +3934,10 @@
               </a:defRPr>
             </a:pPr>
             <a:r>
-              <a:t>Orca</a:t>
-            </a:r>
+              <a:rPr lang="en-US" dirty="0" err="1"/>
+              <a:t>PayLock</a:t>
+            </a:r>
+            <a:endParaRPr dirty="0"/>
           </a:p>
         </p:txBody>
       </p:sp>
@@ -4168,7 +4228,7 @@
         <p:spPr>
           <a:xfrm>
             <a:off x="731520" y="1920240"/>
-            <a:ext cx="10058400" cy="457200"/>
+            <a:ext cx="10058400" cy="369332"/>
           </a:xfrm>
           <a:prstGeom prst="rect">
             <a:avLst/>
@@ -4190,7 +4250,20 @@
               </a:defRPr>
             </a:pPr>
             <a:r>
-              <a:t>什麼是 Orca？</a:t>
+              <a:rPr dirty="0" err="1"/>
+              <a:t>什麼是</a:t>
+            </a:r>
+            <a:r>
+              <a:rPr dirty="0"/>
+              <a:t> </a:t>
+            </a:r>
+            <a:r>
+              <a:rPr lang="en-US" dirty="0" err="1"/>
+              <a:t>PayLock</a:t>
+            </a:r>
+            <a:r>
+              <a:rPr dirty="0"/>
+              <a:t>？</a:t>
             </a:r>
           </a:p>
         </p:txBody>

</xml_diff>